<commit_message>
Update fixed-budget docs with stage3 asymmetric BCE results
</commit_message>
<xml_diff>
--- a/research/fixed_budget_progression_20260323_zh.pptx
+++ b/research/fixed_budget_progression_20260323_zh.pptx
@@ -17,6 +17,7 @@
     <p:sldId id="265" r:id="rId16"/>
     <p:sldId id="266" r:id="rId17"/>
     <p:sldId id="267" r:id="rId18"/>
+    <p:sldId id="268" r:id="rId19"/>
   </p:sldIdLst>
   <p:sldSz cx="12191695" cy="6858000" type="screen4x3"/>
   <p:notesSz cx="6858000" cy="9144000"/>
@@ -3210,7 +3211,7 @@
           <a:lstStyle/>
           <a:p>
             <a:r>
-              <a:t>简化主线的结论</a:t>
+              <a:t>近期尝试但未成立的方法</a:t>
             </a:r>
           </a:p>
         </p:txBody>
@@ -3241,31 +3242,31 @@
               <a:defRPr sz="2200"/>
             </a:pPr>
             <a:r>
-              <a:t>noaffine full：84.18 / 61.57 / 49.58，说明 affine 有帮助但不是主驱动。</a:t>
-            </a:r>
-          </a:p>
-          <a:p>
-            <a:pPr>
-              <a:defRPr sz="2200"/>
-            </a:pPr>
-            <a:r>
-              <a:t>adapter8 full：85.96 / 61.39 / 49.11，可作更轻版本，但不是最佳。</a:t>
-            </a:r>
-          </a:p>
-          <a:p>
-            <a:pPr>
-              <a:defRPr sz="2200"/>
-            </a:pPr>
-            <a:r>
-              <a:t>adapter12 short 明显不行。</a:t>
-            </a:r>
-          </a:p>
-          <a:p>
-            <a:pPr>
-              <a:defRPr sz="2200"/>
-            </a:pPr>
-            <a:r>
-              <a:t>因此当前更像：保留 adapter16，是否保留 affine 取决于论文取舍。</a:t>
+              <a:t>s2curce family：0.1 short 很强，但 0.1/0.05 的 full 都崩。</a:t>
+            </a:r>
+          </a:p>
+          <a:p>
+            <a:pPr>
+              <a:defRPr sz="2200"/>
+            </a:pPr>
+            <a:r>
+              <a:t>stage2 balanced finetune：方向有启发，但不如主线稳。</a:t>
+            </a:r>
+          </a:p>
+          <a:p>
+            <a:pPr>
+              <a:defRPr sz="2200"/>
+            </a:pPr>
+            <a:r>
+              <a:t>stage2-only feature distill 前移：没有让方法更通用。</a:t>
+            </a:r>
+          </a:p>
+          <a:p>
+            <a:pPr>
+              <a:defRPr sz="2200"/>
+            </a:pPr>
+            <a:r>
+              <a:t>单纯增加 stage2 训练预算到 14：没有提升 task2，反而破坏平衡。</a:t>
             </a:r>
           </a:p>
         </p:txBody>
@@ -3304,7 +3305,7 @@
           <a:lstStyle/>
           <a:p>
             <a:r>
-              <a:t>关于 epochs 的最新结论</a:t>
+              <a:t>简化主线的结论</a:t>
             </a:r>
           </a:p>
         </p:txBody>
@@ -3335,23 +3336,31 @@
               <a:defRPr sz="2200"/>
             </a:pPr>
             <a:r>
-              <a:t>同主线在 10,12,12 下：84.72 / 60.96 / 50.54（short）</a:t>
-            </a:r>
-          </a:p>
-          <a:p>
-            <a:pPr>
-              <a:defRPr sz="2200"/>
-            </a:pPr>
-            <a:r>
-              <a:t>同主线在 30-epoch 口径下：近期结果反而混入了训练时长效应。</a:t>
-            </a:r>
-          </a:p>
-          <a:p>
-            <a:pPr>
-              <a:defRPr sz="2200"/>
-            </a:pPr>
-            <a:r>
-              <a:t>现在推荐：主表统一用 10,12,12；30/30/30 只作为补充收敛性检查。</a:t>
+              <a:t>noaffine full：84.18 / 61.57 / 49.58，说明 affine 有帮助但不是主驱动。</a:t>
+            </a:r>
+          </a:p>
+          <a:p>
+            <a:pPr>
+              <a:defRPr sz="2200"/>
+            </a:pPr>
+            <a:r>
+              <a:t>adapter8 full：85.96 / 61.39 / 49.11，可作更轻版本，但不是最佳。</a:t>
+            </a:r>
+          </a:p>
+          <a:p>
+            <a:pPr>
+              <a:defRPr sz="2200"/>
+            </a:pPr>
+            <a:r>
+              <a:t>adapter12 short 明显不行。</a:t>
+            </a:r>
+          </a:p>
+          <a:p>
+            <a:pPr>
+              <a:defRPr sz="2200"/>
+            </a:pPr>
+            <a:r>
+              <a:t>因此当前更像：保留 adapter16，是否保留 affine 取决于论文取舍。</a:t>
             </a:r>
           </a:p>
         </p:txBody>
@@ -3390,7 +3399,7 @@
           <a:lstStyle/>
           <a:p>
             <a:r>
-              <a:t>后续更值得做的方向</a:t>
+              <a:t>关于 epochs 的最新结论</a:t>
             </a:r>
           </a:p>
         </p:txBody>
@@ -3421,6 +3430,92 @@
               <a:defRPr sz="2200"/>
             </a:pPr>
             <a:r>
+              <a:t>同主线在 10,12,12 下：84.72 / 60.96 / 50.54（short）</a:t>
+            </a:r>
+          </a:p>
+          <a:p>
+            <a:pPr>
+              <a:defRPr sz="2200"/>
+            </a:pPr>
+            <a:r>
+              <a:t>同主线在 30-epoch 口径下：近期结果反而混入了训练时长效应。</a:t>
+            </a:r>
+          </a:p>
+          <a:p>
+            <a:pPr>
+              <a:defRPr sz="2200"/>
+            </a:pPr>
+            <a:r>
+              <a:t>现在推荐：主表统一用 10,12,12；30/30/30 只作为补充收敛性检查。</a:t>
+            </a:r>
+          </a:p>
+        </p:txBody>
+      </p:sp>
+    </p:spTree>
+  </p:cSld>
+  <p:clrMapOvr>
+    <a:masterClrMapping/>
+  </p:clrMapOvr>
+</p:sld>
+</file>
+
+<file path=ppt/slides/slide13.xml><?xml version="1.0" encoding="utf-8"?>
+<p:sld xmlns:a="http://schemas.openxmlformats.org/drawingml/2006/main" xmlns:p="http://schemas.openxmlformats.org/presentationml/2006/main" xmlns:r="http://schemas.openxmlformats.org/officeDocument/2006/relationships">
+  <p:cSld>
+    <p:spTree>
+      <p:nvGrpSpPr>
+        <p:cNvPr id="1" name=""/>
+        <p:cNvGrpSpPr/>
+        <p:nvPr/>
+      </p:nvGrpSpPr>
+      <p:grpSpPr/>
+      <p:sp>
+        <p:nvSpPr>
+          <p:cNvPr id="2" name="Title 1"/>
+          <p:cNvSpPr>
+            <a:spLocks noGrp="1"/>
+          </p:cNvSpPr>
+          <p:nvPr>
+            <p:ph type="title"/>
+          </p:nvPr>
+        </p:nvSpPr>
+        <p:spPr/>
+        <p:txBody>
+          <a:bodyPr/>
+          <a:lstStyle/>
+          <a:p>
+            <a:r>
+              <a:t>后续更值得做的方向</a:t>
+            </a:r>
+          </a:p>
+        </p:txBody>
+      </p:sp>
+      <p:sp>
+        <p:nvSpPr>
+          <p:cNvPr id="3" name="TextBox 2"/>
+          <p:cNvSpPr txBox="1"/>
+          <p:nvPr/>
+        </p:nvSpPr>
+        <p:spPr>
+          <a:xfrm>
+            <a:off x="731520" y="1280160"/>
+            <a:ext cx="10515600" cy="4937760"/>
+          </a:xfrm>
+          <a:prstGeom prst="rect">
+            <a:avLst/>
+          </a:prstGeom>
+          <a:noFill/>
+        </p:spPr>
+        <p:txBody>
+          <a:bodyPr wrap="square">
+            <a:spAutoFit/>
+          </a:bodyPr>
+          <a:lstStyle/>
+          <a:p>
+            <a:pPr>
+              <a:defRPr sz="2200"/>
+            </a:pPr>
+            <a:r>
               <a:t>继续围绕 stage2 的缺失旧类处理，而不是继续叠 stage3 patch。</a:t>
             </a:r>
           </a:p>
@@ -3429,7 +3524,7 @@
               <a:defRPr sz="2200"/>
             </a:pPr>
             <a:r>
-              <a:t>优先尝试：更温和、更稳的 stage2 old-class treatment。</a:t>
+              <a:t>优先尝试：更温和、更稳的 stage2 missing-class treatment。</a:t>
             </a:r>
           </a:p>
           <a:p>
@@ -4110,7 +4205,7 @@
           <a:lstStyle/>
           <a:p>
             <a:r>
-              <a:t>近期尝试但未成立的方法</a:t>
+              <a:t>它能推广到 Stage3 吗</a:t>
             </a:r>
           </a:p>
         </p:txBody>
@@ -4141,31 +4236,31 @@
               <a:defRPr sz="2200"/>
             </a:pPr>
             <a:r>
-              <a:t>s2curce family：0.1 short 很强，但 0.1/0.05 的 full 都崩。</a:t>
-            </a:r>
-          </a:p>
-          <a:p>
-            <a:pPr>
-              <a:defRPr sz="2200"/>
-            </a:pPr>
-            <a:r>
-              <a:t>stage2 balanced finetune：方向有启发，但不如主线稳。</a:t>
-            </a:r>
-          </a:p>
-          <a:p>
-            <a:pPr>
-              <a:defRPr sz="2200"/>
-            </a:pPr>
-            <a:r>
-              <a:t>stage2-only feature distill 前移：没有让方法更通用。</a:t>
-            </a:r>
-          </a:p>
-          <a:p>
-            <a:pPr>
-              <a:defRPr sz="2200"/>
-            </a:pPr>
-            <a:r>
-              <a:t>单纯增加 stage2 训练预算到 14：没有提升 task2，反而破坏平衡。</a:t>
+              <a:t>s2ace00_s3ace25_stage101212_short：84.72 / 60.96 / 49.61</a:t>
+            </a:r>
+          </a:p>
+          <a:p>
+            <a:pPr>
+              <a:defRPr sz="2200"/>
+            </a:pPr>
+            <a:r>
+              <a:t>s2ace00_s3ace00_stage101212_short：84.72 / 60.96 / 49.69</a:t>
+            </a:r>
+          </a:p>
+          <a:p>
+            <a:pPr>
+              <a:defRPr sz="2200"/>
+            </a:pPr>
+            <a:r>
+              <a:t>同口径主线：84.72 / 60.96 / 50.54</a:t>
+            </a:r>
+          </a:p>
+          <a:p>
+            <a:pPr>
+              <a:defRPr sz="2200"/>
+            </a:pPr>
+            <a:r>
+              <a:t>结论：asymmetric BCE 的思想成立，但当前最有效的作用阶段仍然是 stage2，不应简单机械推广到 stage3。</a:t>
             </a:r>
           </a:p>
         </p:txBody>

</xml_diff>